<commit_message>
test(template-e2e): owned-fixture reorder/clone regression + broken-import path
- slideTexts identification replaces the first-text heuristic: duplicated
  pages carry the cover title as their first text element, so page identity
  uses the full per-page text signature.
- contentPage now writes to the duplicated LAST slide (previous writes landed
  on the cover), generator version bumped so stale fixtures regenerate.
- owned spec gains the broken-template path: garbage bytes import shows the
  typed error in the panel and the app keeps running (GOAL §41/§26).
- full E2E suite: 13 passed + 1 environment-skipped (Gorden panel spec).
</commit_message>
<xml_diff>
--- a/e2e/fixtures/templates/business-report.pptx
+++ b/e2e/fixtures/templates/business-report.pptx
@@ -6,6 +6,10 @@
   </p:sldMasterIdLst>
   <p:sldIdLst>
     <p:sldId id="256" r:id="rId2"/>
+    <p:sldId id="257" r:id="rId3"/>
+    <p:sldId id="258" r:id="rId4"/>
+    <p:sldId id="259" r:id="rId5"/>
+    <p:sldId id="260" r:id="rId6"/>
   </p:sldIdLst>
   <p:sldSz cx="12192000" cy="6858000"/>
   <p:notesSz cx="6858000" cy="9144000"/>
@@ -90,7 +94,7 @@
           <p:cNvPr id="2" name="TextBox 2">
             <a:extLst>
               <a:ext uri="{FF2B5EF4-FFF2-40B4-BE49-F238E27FC236}">
-                <a16:creationId xmlns:a16="http://schemas.microsoft.com/office/drawing/2014/main" id="{0896E0A0-AB24-4096-B013-EB03D8520F72}"/>
+                <a16:creationId xmlns:a16="http://schemas.microsoft.com/office/drawing/2014/main" id="{6FB11581-0C26-43D4-8C6A-0E282C0D9C16}"/>
               </a:ext>
             </a:extLst>
           </p:cNvPr>
@@ -119,7 +123,7 @@
           <p:cNvPr id="3" name="TextBox 3">
             <a:extLst>
               <a:ext uri="{FF2B5EF4-FFF2-40B4-BE49-F238E27FC236}">
-                <a16:creationId xmlns:a16="http://schemas.microsoft.com/office/drawing/2014/main" id="{C73D6F82-B0A3-45F6-B846-60EFDC681236}"/>
+                <a16:creationId xmlns:a16="http://schemas.microsoft.com/office/drawing/2014/main" id="{E1C77518-5742-4A24-8C80-9490E4A6B42D}"/>
               </a:ext>
             </a:extLst>
           </p:cNvPr>
@@ -143,12 +147,95 @@
           </a:p>
         </p:txBody>
       </p:sp>
+    </p:spTree>
+  </p:cSld>
+  <p:clrMapOvr>
+    <a:masterClrMapping/>
+  </p:clrMapOvr>
+</p:sld>
+</file>
+
+<file path=ppt/slides/slide2.xml><?xml version="1.0" encoding="utf-8"?>
+<p:sld xmlns:a="http://schemas.openxmlformats.org/drawingml/2006/main" xmlns:r="http://schemas.openxmlformats.org/officeDocument/2006/relationships" xmlns:p="http://schemas.openxmlformats.org/presentationml/2006/main">
+  <p:cSld>
+    <p:spTree>
+      <p:nvGrpSpPr>
+        <p:cNvPr id="1" name=""/>
+        <p:cNvGrpSpPr/>
+        <p:nvPr/>
+      </p:nvGrpSpPr>
+      <p:grpSpPr>
+        <a:xfrm>
+          <a:off x="0" y="0"/>
+          <a:ext cx="0" cy="0"/>
+          <a:chOff x="0" y="0"/>
+          <a:chExt cx="0" cy="0"/>
+        </a:xfrm>
+      </p:grpSpPr>
+      <p:sp>
+        <p:nvSpPr>
+          <p:cNvPr id="2" name="TextBox 2">
+            <a:extLst>
+              <a:ext uri="{FF2B5EF4-FFF2-40B4-BE49-F238E27FC236}">
+                <a16:creationId xmlns:a16="http://schemas.microsoft.com/office/drawing/2014/main" id="{6FB11581-0C26-43D4-8C6A-0E282C0D9C16}"/>
+              </a:ext>
+            </a:extLst>
+          </p:cNvPr>
+          <p:cNvSpPr txBox="1"/>
+          <p:nvPr/>
+        </p:nvSpPr>
+        <p:spPr>
+          <a:xfrm>
+            <a:off x="914400" y="1828800"/>
+            <a:ext cx="9906000" cy="1371600"/>
+          </a:xfrm>
+        </p:spPr>
+        <p:txBody>
+          <a:bodyPr wrap="square" rtlCol="0"/>
+          <a:lstStyle/>
+          <a:p>
+            <a:r>
+              <a:rPr sz="3600" b="1"/>
+              <a:t>Business Report</a:t>
+            </a:r>
+          </a:p>
+        </p:txBody>
+      </p:sp>
+      <p:sp>
+        <p:nvSpPr>
+          <p:cNvPr id="3" name="TextBox 3">
+            <a:extLst>
+              <a:ext uri="{FF2B5EF4-FFF2-40B4-BE49-F238E27FC236}">
+                <a16:creationId xmlns:a16="http://schemas.microsoft.com/office/drawing/2014/main" id="{E1C77518-5742-4A24-8C80-9490E4A6B42D}"/>
+              </a:ext>
+            </a:extLst>
+          </p:cNvPr>
+          <p:cNvSpPr txBox="1"/>
+          <p:nvPr/>
+        </p:nvSpPr>
+        <p:spPr>
+          <a:xfrm>
+            <a:off x="914400" y="3200400"/>
+            <a:ext cx="9906000" cy="914400"/>
+          </a:xfrm>
+        </p:spPr>
+        <p:txBody>
+          <a:bodyPr wrap="square" rtlCol="0"/>
+          <a:lstStyle/>
+          <a:p>
+            <a:r>
+              <a:rPr sz="1800"/>
+              <a:t>Quarterly review deck</a:t>
+            </a:r>
+          </a:p>
+        </p:txBody>
+      </p:sp>
       <p:sp>
         <p:nvSpPr>
           <p:cNvPr id="4" name="TextBox 4">
             <a:extLst>
               <a:ext uri="{FF2B5EF4-FFF2-40B4-BE49-F238E27FC236}">
-                <a16:creationId xmlns:a16="http://schemas.microsoft.com/office/drawing/2014/main" id="{CD71CA59-8B4A-4120-8837-6FD99C37858C}"/>
+                <a16:creationId xmlns:a16="http://schemas.microsoft.com/office/drawing/2014/main" id="{E2A19419-8CE1-4FD5-9212-0B2FE4B7EB34}"/>
               </a:ext>
             </a:extLst>
           </p:cNvPr>
@@ -177,7 +264,7 @@
           <p:cNvPr id="5" name="TextBox 5">
             <a:extLst>
               <a:ext uri="{FF2B5EF4-FFF2-40B4-BE49-F238E27FC236}">
-                <a16:creationId xmlns:a16="http://schemas.microsoft.com/office/drawing/2014/main" id="{875D5A18-59C9-4725-AA90-DCD354F9B6C7}"/>
+                <a16:creationId xmlns:a16="http://schemas.microsoft.com/office/drawing/2014/main" id="{C0544699-0B20-4924-8B79-9F9CBBF6A3E5}"/>
               </a:ext>
             </a:extLst>
           </p:cNvPr>
@@ -201,12 +288,153 @@
           </a:p>
         </p:txBody>
       </p:sp>
+    </p:spTree>
+  </p:cSld>
+  <p:clrMapOvr>
+    <a:masterClrMapping/>
+  </p:clrMapOvr>
+</p:sld>
+</file>
+
+<file path=ppt/slides/slide3.xml><?xml version="1.0" encoding="utf-8"?>
+<p:sld xmlns:a="http://schemas.openxmlformats.org/drawingml/2006/main" xmlns:r="http://schemas.openxmlformats.org/officeDocument/2006/relationships" xmlns:p="http://schemas.openxmlformats.org/presentationml/2006/main">
+  <p:cSld>
+    <p:spTree>
+      <p:nvGrpSpPr>
+        <p:cNvPr id="1" name=""/>
+        <p:cNvGrpSpPr/>
+        <p:nvPr/>
+      </p:nvGrpSpPr>
+      <p:grpSpPr>
+        <a:xfrm>
+          <a:off x="0" y="0"/>
+          <a:ext cx="0" cy="0"/>
+          <a:chOff x="0" y="0"/>
+          <a:chExt cx="0" cy="0"/>
+        </a:xfrm>
+      </p:grpSpPr>
+      <p:sp>
+        <p:nvSpPr>
+          <p:cNvPr id="2" name="TextBox 2">
+            <a:extLst>
+              <a:ext uri="{FF2B5EF4-FFF2-40B4-BE49-F238E27FC236}">
+                <a16:creationId xmlns:a16="http://schemas.microsoft.com/office/drawing/2014/main" id="{6FB11581-0C26-43D4-8C6A-0E282C0D9C16}"/>
+              </a:ext>
+            </a:extLst>
+          </p:cNvPr>
+          <p:cNvSpPr txBox="1"/>
+          <p:nvPr/>
+        </p:nvSpPr>
+        <p:spPr>
+          <a:xfrm>
+            <a:off x="914400" y="1828800"/>
+            <a:ext cx="9906000" cy="1371600"/>
+          </a:xfrm>
+        </p:spPr>
+        <p:txBody>
+          <a:bodyPr wrap="square" rtlCol="0"/>
+          <a:lstStyle/>
+          <a:p>
+            <a:r>
+              <a:rPr sz="3600" b="1"/>
+              <a:t>Business Report</a:t>
+            </a:r>
+          </a:p>
+        </p:txBody>
+      </p:sp>
+      <p:sp>
+        <p:nvSpPr>
+          <p:cNvPr id="3" name="TextBox 3">
+            <a:extLst>
+              <a:ext uri="{FF2B5EF4-FFF2-40B4-BE49-F238E27FC236}">
+                <a16:creationId xmlns:a16="http://schemas.microsoft.com/office/drawing/2014/main" id="{E1C77518-5742-4A24-8C80-9490E4A6B42D}"/>
+              </a:ext>
+            </a:extLst>
+          </p:cNvPr>
+          <p:cNvSpPr txBox="1"/>
+          <p:nvPr/>
+        </p:nvSpPr>
+        <p:spPr>
+          <a:xfrm>
+            <a:off x="914400" y="3200400"/>
+            <a:ext cx="9906000" cy="914400"/>
+          </a:xfrm>
+        </p:spPr>
+        <p:txBody>
+          <a:bodyPr wrap="square" rtlCol="0"/>
+          <a:lstStyle/>
+          <a:p>
+            <a:r>
+              <a:rPr sz="1800"/>
+              <a:t>Quarterly review deck</a:t>
+            </a:r>
+          </a:p>
+        </p:txBody>
+      </p:sp>
+      <p:sp>
+        <p:nvSpPr>
+          <p:cNvPr id="4" name="TextBox 4">
+            <a:extLst>
+              <a:ext uri="{FF2B5EF4-FFF2-40B4-BE49-F238E27FC236}">
+                <a16:creationId xmlns:a16="http://schemas.microsoft.com/office/drawing/2014/main" id="{E2A19419-8CE1-4FD5-9212-0B2FE4B7EB34}"/>
+              </a:ext>
+            </a:extLst>
+          </p:cNvPr>
+          <p:cNvSpPr txBox="1"/>
+          <p:nvPr/>
+        </p:nvSpPr>
+        <p:spPr>
+          <a:xfrm>
+            <a:off x="914400" y="457200"/>
+            <a:ext cx="9906000" cy="914400"/>
+          </a:xfrm>
+        </p:spPr>
+        <p:txBody>
+          <a:bodyPr wrap="square" rtlCol="0"/>
+          <a:lstStyle/>
+          <a:p>
+            <a:r>
+              <a:rPr sz="2400" b="1"/>
+              <a:t>Highlights</a:t>
+            </a:r>
+          </a:p>
+        </p:txBody>
+      </p:sp>
+      <p:sp>
+        <p:nvSpPr>
+          <p:cNvPr id="5" name="TextBox 5">
+            <a:extLst>
+              <a:ext uri="{FF2B5EF4-FFF2-40B4-BE49-F238E27FC236}">
+                <a16:creationId xmlns:a16="http://schemas.microsoft.com/office/drawing/2014/main" id="{C0544699-0B20-4924-8B79-9F9CBBF6A3E5}"/>
+              </a:ext>
+            </a:extLst>
+          </p:cNvPr>
+          <p:cNvSpPr txBox="1"/>
+          <p:nvPr/>
+        </p:nvSpPr>
+        <p:spPr>
+          <a:xfrm>
+            <a:off x="914400" y="1371600"/>
+            <a:ext cx="9906000" cy="4572000"/>
+          </a:xfrm>
+        </p:spPr>
+        <p:txBody>
+          <a:bodyPr wrap="square" rtlCol="0"/>
+          <a:lstStyle/>
+          <a:p>
+            <a:r>
+              <a:rPr sz="1400"/>
+              <a:t>Highlights for the business review fixture.</a:t>
+            </a:r>
+          </a:p>
+        </p:txBody>
+      </p:sp>
       <p:sp>
         <p:nvSpPr>
           <p:cNvPr id="6" name="TextBox 6">
             <a:extLst>
               <a:ext uri="{FF2B5EF4-FFF2-40B4-BE49-F238E27FC236}">
-                <a16:creationId xmlns:a16="http://schemas.microsoft.com/office/drawing/2014/main" id="{86791675-C0F6-4EC3-9A14-73ED4E8A2611}"/>
+                <a16:creationId xmlns:a16="http://schemas.microsoft.com/office/drawing/2014/main" id="{8E57C9D9-4D28-423E-A261-647A60B597EB}"/>
               </a:ext>
             </a:extLst>
           </p:cNvPr>
@@ -235,7 +463,7 @@
           <p:cNvPr id="7" name="TextBox 7">
             <a:extLst>
               <a:ext uri="{FF2B5EF4-FFF2-40B4-BE49-F238E27FC236}">
-                <a16:creationId xmlns:a16="http://schemas.microsoft.com/office/drawing/2014/main" id="{7594E8AB-DC11-40DD-AAA1-3FCC2C53E78F}"/>
+                <a16:creationId xmlns:a16="http://schemas.microsoft.com/office/drawing/2014/main" id="{3FBECD4E-E64A-472F-9517-61C889ECB723}"/>
               </a:ext>
             </a:extLst>
           </p:cNvPr>
@@ -259,12 +487,211 @@
           </a:p>
         </p:txBody>
       </p:sp>
+    </p:spTree>
+  </p:cSld>
+  <p:clrMapOvr>
+    <a:masterClrMapping/>
+  </p:clrMapOvr>
+</p:sld>
+</file>
+
+<file path=ppt/slides/slide4.xml><?xml version="1.0" encoding="utf-8"?>
+<p:sld xmlns:a="http://schemas.openxmlformats.org/drawingml/2006/main" xmlns:r="http://schemas.openxmlformats.org/officeDocument/2006/relationships" xmlns:p="http://schemas.openxmlformats.org/presentationml/2006/main">
+  <p:cSld>
+    <p:spTree>
+      <p:nvGrpSpPr>
+        <p:cNvPr id="1" name=""/>
+        <p:cNvGrpSpPr/>
+        <p:nvPr/>
+      </p:nvGrpSpPr>
+      <p:grpSpPr>
+        <a:xfrm>
+          <a:off x="0" y="0"/>
+          <a:ext cx="0" cy="0"/>
+          <a:chOff x="0" y="0"/>
+          <a:chExt cx="0" cy="0"/>
+        </a:xfrm>
+      </p:grpSpPr>
+      <p:sp>
+        <p:nvSpPr>
+          <p:cNvPr id="2" name="TextBox 2">
+            <a:extLst>
+              <a:ext uri="{FF2B5EF4-FFF2-40B4-BE49-F238E27FC236}">
+                <a16:creationId xmlns:a16="http://schemas.microsoft.com/office/drawing/2014/main" id="{6FB11581-0C26-43D4-8C6A-0E282C0D9C16}"/>
+              </a:ext>
+            </a:extLst>
+          </p:cNvPr>
+          <p:cNvSpPr txBox="1"/>
+          <p:nvPr/>
+        </p:nvSpPr>
+        <p:spPr>
+          <a:xfrm>
+            <a:off x="914400" y="1828800"/>
+            <a:ext cx="9906000" cy="1371600"/>
+          </a:xfrm>
+        </p:spPr>
+        <p:txBody>
+          <a:bodyPr wrap="square" rtlCol="0"/>
+          <a:lstStyle/>
+          <a:p>
+            <a:r>
+              <a:rPr sz="3600" b="1"/>
+              <a:t>Business Report</a:t>
+            </a:r>
+          </a:p>
+        </p:txBody>
+      </p:sp>
+      <p:sp>
+        <p:nvSpPr>
+          <p:cNvPr id="3" name="TextBox 3">
+            <a:extLst>
+              <a:ext uri="{FF2B5EF4-FFF2-40B4-BE49-F238E27FC236}">
+                <a16:creationId xmlns:a16="http://schemas.microsoft.com/office/drawing/2014/main" id="{E1C77518-5742-4A24-8C80-9490E4A6B42D}"/>
+              </a:ext>
+            </a:extLst>
+          </p:cNvPr>
+          <p:cNvSpPr txBox="1"/>
+          <p:nvPr/>
+        </p:nvSpPr>
+        <p:spPr>
+          <a:xfrm>
+            <a:off x="914400" y="3200400"/>
+            <a:ext cx="9906000" cy="914400"/>
+          </a:xfrm>
+        </p:spPr>
+        <p:txBody>
+          <a:bodyPr wrap="square" rtlCol="0"/>
+          <a:lstStyle/>
+          <a:p>
+            <a:r>
+              <a:rPr sz="1800"/>
+              <a:t>Quarterly review deck</a:t>
+            </a:r>
+          </a:p>
+        </p:txBody>
+      </p:sp>
+      <p:sp>
+        <p:nvSpPr>
+          <p:cNvPr id="4" name="TextBox 4">
+            <a:extLst>
+              <a:ext uri="{FF2B5EF4-FFF2-40B4-BE49-F238E27FC236}">
+                <a16:creationId xmlns:a16="http://schemas.microsoft.com/office/drawing/2014/main" id="{E2A19419-8CE1-4FD5-9212-0B2FE4B7EB34}"/>
+              </a:ext>
+            </a:extLst>
+          </p:cNvPr>
+          <p:cNvSpPr txBox="1"/>
+          <p:nvPr/>
+        </p:nvSpPr>
+        <p:spPr>
+          <a:xfrm>
+            <a:off x="914400" y="457200"/>
+            <a:ext cx="9906000" cy="914400"/>
+          </a:xfrm>
+        </p:spPr>
+        <p:txBody>
+          <a:bodyPr wrap="square" rtlCol="0"/>
+          <a:lstStyle/>
+          <a:p>
+            <a:r>
+              <a:rPr sz="2400" b="1"/>
+              <a:t>Highlights</a:t>
+            </a:r>
+          </a:p>
+        </p:txBody>
+      </p:sp>
+      <p:sp>
+        <p:nvSpPr>
+          <p:cNvPr id="5" name="TextBox 5">
+            <a:extLst>
+              <a:ext uri="{FF2B5EF4-FFF2-40B4-BE49-F238E27FC236}">
+                <a16:creationId xmlns:a16="http://schemas.microsoft.com/office/drawing/2014/main" id="{C0544699-0B20-4924-8B79-9F9CBBF6A3E5}"/>
+              </a:ext>
+            </a:extLst>
+          </p:cNvPr>
+          <p:cNvSpPr txBox="1"/>
+          <p:nvPr/>
+        </p:nvSpPr>
+        <p:spPr>
+          <a:xfrm>
+            <a:off x="914400" y="1371600"/>
+            <a:ext cx="9906000" cy="4572000"/>
+          </a:xfrm>
+        </p:spPr>
+        <p:txBody>
+          <a:bodyPr wrap="square" rtlCol="0"/>
+          <a:lstStyle/>
+          <a:p>
+            <a:r>
+              <a:rPr sz="1400"/>
+              <a:t>Highlights for the business review fixture.</a:t>
+            </a:r>
+          </a:p>
+        </p:txBody>
+      </p:sp>
+      <p:sp>
+        <p:nvSpPr>
+          <p:cNvPr id="6" name="TextBox 6">
+            <a:extLst>
+              <a:ext uri="{FF2B5EF4-FFF2-40B4-BE49-F238E27FC236}">
+                <a16:creationId xmlns:a16="http://schemas.microsoft.com/office/drawing/2014/main" id="{8E57C9D9-4D28-423E-A261-647A60B597EB}"/>
+              </a:ext>
+            </a:extLst>
+          </p:cNvPr>
+          <p:cNvSpPr txBox="1"/>
+          <p:nvPr/>
+        </p:nvSpPr>
+        <p:spPr>
+          <a:xfrm>
+            <a:off x="914400" y="457200"/>
+            <a:ext cx="9906000" cy="914400"/>
+          </a:xfrm>
+        </p:spPr>
+        <p:txBody>
+          <a:bodyPr wrap="square" rtlCol="0"/>
+          <a:lstStyle/>
+          <a:p>
+            <a:r>
+              <a:rPr sz="2400" b="1"/>
+              <a:t>Risks</a:t>
+            </a:r>
+          </a:p>
+        </p:txBody>
+      </p:sp>
+      <p:sp>
+        <p:nvSpPr>
+          <p:cNvPr id="7" name="TextBox 7">
+            <a:extLst>
+              <a:ext uri="{FF2B5EF4-FFF2-40B4-BE49-F238E27FC236}">
+                <a16:creationId xmlns:a16="http://schemas.microsoft.com/office/drawing/2014/main" id="{3FBECD4E-E64A-472F-9517-61C889ECB723}"/>
+              </a:ext>
+            </a:extLst>
+          </p:cNvPr>
+          <p:cNvSpPr txBox="1"/>
+          <p:nvPr/>
+        </p:nvSpPr>
+        <p:spPr>
+          <a:xfrm>
+            <a:off x="914400" y="1371600"/>
+            <a:ext cx="9906000" cy="4572000"/>
+          </a:xfrm>
+        </p:spPr>
+        <p:txBody>
+          <a:bodyPr wrap="square" rtlCol="0"/>
+          <a:lstStyle/>
+          <a:p>
+            <a:r>
+              <a:rPr sz="1400"/>
+              <a:t>Risks for the business review fixture.</a:t>
+            </a:r>
+          </a:p>
+        </p:txBody>
+      </p:sp>
       <p:sp>
         <p:nvSpPr>
           <p:cNvPr id="8" name="TextBox 8">
             <a:extLst>
               <a:ext uri="{FF2B5EF4-FFF2-40B4-BE49-F238E27FC236}">
-                <a16:creationId xmlns:a16="http://schemas.microsoft.com/office/drawing/2014/main" id="{820EF230-BCC8-4F54-829D-538CA5111FA5}"/>
+                <a16:creationId xmlns:a16="http://schemas.microsoft.com/office/drawing/2014/main" id="{8CDD7FCE-C50F-4011-AAB6-FE91C26E9A13}"/>
               </a:ext>
             </a:extLst>
           </p:cNvPr>
@@ -293,7 +720,7 @@
           <p:cNvPr id="9" name="TextBox 9">
             <a:extLst>
               <a:ext uri="{FF2B5EF4-FFF2-40B4-BE49-F238E27FC236}">
-                <a16:creationId xmlns:a16="http://schemas.microsoft.com/office/drawing/2014/main" id="{CD6518A0-B291-47AF-838A-9694001A6C2C}"/>
+                <a16:creationId xmlns:a16="http://schemas.microsoft.com/office/drawing/2014/main" id="{84CD9F61-C46D-45E1-A373-DD4CE78B0089}"/>
               </a:ext>
             </a:extLst>
           </p:cNvPr>
@@ -317,12 +744,269 @@
           </a:p>
         </p:txBody>
       </p:sp>
+    </p:spTree>
+  </p:cSld>
+  <p:clrMapOvr>
+    <a:masterClrMapping/>
+  </p:clrMapOvr>
+</p:sld>
+</file>
+
+<file path=ppt/slides/slide5.xml><?xml version="1.0" encoding="utf-8"?>
+<p:sld xmlns:a="http://schemas.openxmlformats.org/drawingml/2006/main" xmlns:r="http://schemas.openxmlformats.org/officeDocument/2006/relationships" xmlns:p="http://schemas.openxmlformats.org/presentationml/2006/main">
+  <p:cSld>
+    <p:spTree>
+      <p:nvGrpSpPr>
+        <p:cNvPr id="1" name=""/>
+        <p:cNvGrpSpPr/>
+        <p:nvPr/>
+      </p:nvGrpSpPr>
+      <p:grpSpPr>
+        <a:xfrm>
+          <a:off x="0" y="0"/>
+          <a:ext cx="0" cy="0"/>
+          <a:chOff x="0" y="0"/>
+          <a:chExt cx="0" cy="0"/>
+        </a:xfrm>
+      </p:grpSpPr>
+      <p:sp>
+        <p:nvSpPr>
+          <p:cNvPr id="2" name="TextBox 2">
+            <a:extLst>
+              <a:ext uri="{FF2B5EF4-FFF2-40B4-BE49-F238E27FC236}">
+                <a16:creationId xmlns:a16="http://schemas.microsoft.com/office/drawing/2014/main" id="{6FB11581-0C26-43D4-8C6A-0E282C0D9C16}"/>
+              </a:ext>
+            </a:extLst>
+          </p:cNvPr>
+          <p:cNvSpPr txBox="1"/>
+          <p:nvPr/>
+        </p:nvSpPr>
+        <p:spPr>
+          <a:xfrm>
+            <a:off x="914400" y="1828800"/>
+            <a:ext cx="9906000" cy="1371600"/>
+          </a:xfrm>
+        </p:spPr>
+        <p:txBody>
+          <a:bodyPr wrap="square" rtlCol="0"/>
+          <a:lstStyle/>
+          <a:p>
+            <a:r>
+              <a:rPr sz="3600" b="1"/>
+              <a:t>Business Report</a:t>
+            </a:r>
+          </a:p>
+        </p:txBody>
+      </p:sp>
+      <p:sp>
+        <p:nvSpPr>
+          <p:cNvPr id="3" name="TextBox 3">
+            <a:extLst>
+              <a:ext uri="{FF2B5EF4-FFF2-40B4-BE49-F238E27FC236}">
+                <a16:creationId xmlns:a16="http://schemas.microsoft.com/office/drawing/2014/main" id="{E1C77518-5742-4A24-8C80-9490E4A6B42D}"/>
+              </a:ext>
+            </a:extLst>
+          </p:cNvPr>
+          <p:cNvSpPr txBox="1"/>
+          <p:nvPr/>
+        </p:nvSpPr>
+        <p:spPr>
+          <a:xfrm>
+            <a:off x="914400" y="3200400"/>
+            <a:ext cx="9906000" cy="914400"/>
+          </a:xfrm>
+        </p:spPr>
+        <p:txBody>
+          <a:bodyPr wrap="square" rtlCol="0"/>
+          <a:lstStyle/>
+          <a:p>
+            <a:r>
+              <a:rPr sz="1800"/>
+              <a:t>Quarterly review deck</a:t>
+            </a:r>
+          </a:p>
+        </p:txBody>
+      </p:sp>
+      <p:sp>
+        <p:nvSpPr>
+          <p:cNvPr id="4" name="TextBox 4">
+            <a:extLst>
+              <a:ext uri="{FF2B5EF4-FFF2-40B4-BE49-F238E27FC236}">
+                <a16:creationId xmlns:a16="http://schemas.microsoft.com/office/drawing/2014/main" id="{E2A19419-8CE1-4FD5-9212-0B2FE4B7EB34}"/>
+              </a:ext>
+            </a:extLst>
+          </p:cNvPr>
+          <p:cNvSpPr txBox="1"/>
+          <p:nvPr/>
+        </p:nvSpPr>
+        <p:spPr>
+          <a:xfrm>
+            <a:off x="914400" y="457200"/>
+            <a:ext cx="9906000" cy="914400"/>
+          </a:xfrm>
+        </p:spPr>
+        <p:txBody>
+          <a:bodyPr wrap="square" rtlCol="0"/>
+          <a:lstStyle/>
+          <a:p>
+            <a:r>
+              <a:rPr sz="2400" b="1"/>
+              <a:t>Highlights</a:t>
+            </a:r>
+          </a:p>
+        </p:txBody>
+      </p:sp>
+      <p:sp>
+        <p:nvSpPr>
+          <p:cNvPr id="5" name="TextBox 5">
+            <a:extLst>
+              <a:ext uri="{FF2B5EF4-FFF2-40B4-BE49-F238E27FC236}">
+                <a16:creationId xmlns:a16="http://schemas.microsoft.com/office/drawing/2014/main" id="{C0544699-0B20-4924-8B79-9F9CBBF6A3E5}"/>
+              </a:ext>
+            </a:extLst>
+          </p:cNvPr>
+          <p:cNvSpPr txBox="1"/>
+          <p:nvPr/>
+        </p:nvSpPr>
+        <p:spPr>
+          <a:xfrm>
+            <a:off x="914400" y="1371600"/>
+            <a:ext cx="9906000" cy="4572000"/>
+          </a:xfrm>
+        </p:spPr>
+        <p:txBody>
+          <a:bodyPr wrap="square" rtlCol="0"/>
+          <a:lstStyle/>
+          <a:p>
+            <a:r>
+              <a:rPr sz="1400"/>
+              <a:t>Highlights for the business review fixture.</a:t>
+            </a:r>
+          </a:p>
+        </p:txBody>
+      </p:sp>
+      <p:sp>
+        <p:nvSpPr>
+          <p:cNvPr id="6" name="TextBox 6">
+            <a:extLst>
+              <a:ext uri="{FF2B5EF4-FFF2-40B4-BE49-F238E27FC236}">
+                <a16:creationId xmlns:a16="http://schemas.microsoft.com/office/drawing/2014/main" id="{8E57C9D9-4D28-423E-A261-647A60B597EB}"/>
+              </a:ext>
+            </a:extLst>
+          </p:cNvPr>
+          <p:cNvSpPr txBox="1"/>
+          <p:nvPr/>
+        </p:nvSpPr>
+        <p:spPr>
+          <a:xfrm>
+            <a:off x="914400" y="457200"/>
+            <a:ext cx="9906000" cy="914400"/>
+          </a:xfrm>
+        </p:spPr>
+        <p:txBody>
+          <a:bodyPr wrap="square" rtlCol="0"/>
+          <a:lstStyle/>
+          <a:p>
+            <a:r>
+              <a:rPr sz="2400" b="1"/>
+              <a:t>Risks</a:t>
+            </a:r>
+          </a:p>
+        </p:txBody>
+      </p:sp>
+      <p:sp>
+        <p:nvSpPr>
+          <p:cNvPr id="7" name="TextBox 7">
+            <a:extLst>
+              <a:ext uri="{FF2B5EF4-FFF2-40B4-BE49-F238E27FC236}">
+                <a16:creationId xmlns:a16="http://schemas.microsoft.com/office/drawing/2014/main" id="{3FBECD4E-E64A-472F-9517-61C889ECB723}"/>
+              </a:ext>
+            </a:extLst>
+          </p:cNvPr>
+          <p:cNvSpPr txBox="1"/>
+          <p:nvPr/>
+        </p:nvSpPr>
+        <p:spPr>
+          <a:xfrm>
+            <a:off x="914400" y="1371600"/>
+            <a:ext cx="9906000" cy="4572000"/>
+          </a:xfrm>
+        </p:spPr>
+        <p:txBody>
+          <a:bodyPr wrap="square" rtlCol="0"/>
+          <a:lstStyle/>
+          <a:p>
+            <a:r>
+              <a:rPr sz="1400"/>
+              <a:t>Risks for the business review fixture.</a:t>
+            </a:r>
+          </a:p>
+        </p:txBody>
+      </p:sp>
+      <p:sp>
+        <p:nvSpPr>
+          <p:cNvPr id="8" name="TextBox 8">
+            <a:extLst>
+              <a:ext uri="{FF2B5EF4-FFF2-40B4-BE49-F238E27FC236}">
+                <a16:creationId xmlns:a16="http://schemas.microsoft.com/office/drawing/2014/main" id="{8CDD7FCE-C50F-4011-AAB6-FE91C26E9A13}"/>
+              </a:ext>
+            </a:extLst>
+          </p:cNvPr>
+          <p:cNvSpPr txBox="1"/>
+          <p:nvPr/>
+        </p:nvSpPr>
+        <p:spPr>
+          <a:xfrm>
+            <a:off x="914400" y="457200"/>
+            <a:ext cx="9906000" cy="914400"/>
+          </a:xfrm>
+        </p:spPr>
+        <p:txBody>
+          <a:bodyPr wrap="square" rtlCol="0"/>
+          <a:lstStyle/>
+          <a:p>
+            <a:r>
+              <a:rPr sz="2400" b="1"/>
+              <a:t>Outlook</a:t>
+            </a:r>
+          </a:p>
+        </p:txBody>
+      </p:sp>
+      <p:sp>
+        <p:nvSpPr>
+          <p:cNvPr id="9" name="TextBox 9">
+            <a:extLst>
+              <a:ext uri="{FF2B5EF4-FFF2-40B4-BE49-F238E27FC236}">
+                <a16:creationId xmlns:a16="http://schemas.microsoft.com/office/drawing/2014/main" id="{84CD9F61-C46D-45E1-A373-DD4CE78B0089}"/>
+              </a:ext>
+            </a:extLst>
+          </p:cNvPr>
+          <p:cNvSpPr txBox="1"/>
+          <p:nvPr/>
+        </p:nvSpPr>
+        <p:spPr>
+          <a:xfrm>
+            <a:off x="914400" y="1371600"/>
+            <a:ext cx="9906000" cy="4572000"/>
+          </a:xfrm>
+        </p:spPr>
+        <p:txBody>
+          <a:bodyPr wrap="square" rtlCol="0"/>
+          <a:lstStyle/>
+          <a:p>
+            <a:r>
+              <a:rPr sz="1400"/>
+              <a:t>Outlook for the business review fixture.</a:t>
+            </a:r>
+          </a:p>
+        </p:txBody>
+      </p:sp>
       <p:sp>
         <p:nvSpPr>
           <p:cNvPr id="10" name="TextBox 10">
             <a:extLst>
               <a:ext uri="{FF2B5EF4-FFF2-40B4-BE49-F238E27FC236}">
-                <a16:creationId xmlns:a16="http://schemas.microsoft.com/office/drawing/2014/main" id="{592AE201-E672-4650-A146-1780A3EFB6B8}"/>
+                <a16:creationId xmlns:a16="http://schemas.microsoft.com/office/drawing/2014/main" id="{E95FE9F1-7AE5-4F6F-910C-AEEB945C0164}"/>
               </a:ext>
             </a:extLst>
           </p:cNvPr>
@@ -351,7 +1035,7 @@
           <p:cNvPr id="11" name="TextBox 11">
             <a:extLst>
               <a:ext uri="{FF2B5EF4-FFF2-40B4-BE49-F238E27FC236}">
-                <a16:creationId xmlns:a16="http://schemas.microsoft.com/office/drawing/2014/main" id="{39F04380-86D3-46E6-9AE4-0D46E86F6994}"/>
+                <a16:creationId xmlns:a16="http://schemas.microsoft.com/office/drawing/2014/main" id="{E4D9C918-E5B0-4D45-A713-57EA77642088}"/>
               </a:ext>
             </a:extLst>
           </p:cNvPr>

</xml_diff>

<commit_message>
test(perf): 100-slide analyzer smoke on the owned pressure fixture
- generator gains large-100-slide.pptx (GOAL §40/§42), version bumped so all
  fixtures regenerate
- analyzer perf smoke: 100 slides must parse with full per-slide progress and
  finish well under the 30s CI ceiling (measured ~0.6s locally); self-generates
  its fixture so the template-intelligence CI job runs it non-skipped
- fixture generator return types unified to Uint8Array
</commit_message>
<xml_diff>
--- a/e2e/fixtures/templates/business-report.pptx
+++ b/e2e/fixtures/templates/business-report.pptx
@@ -94,7 +94,7 @@
           <p:cNvPr id="2" name="TextBox 2">
             <a:extLst>
               <a:ext uri="{FF2B5EF4-FFF2-40B4-BE49-F238E27FC236}">
-                <a16:creationId xmlns:a16="http://schemas.microsoft.com/office/drawing/2014/main" id="{6FB11581-0C26-43D4-8C6A-0E282C0D9C16}"/>
+                <a16:creationId xmlns:a16="http://schemas.microsoft.com/office/drawing/2014/main" id="{9114FAF6-B8C5-48AB-958C-C8065373C9AE}"/>
               </a:ext>
             </a:extLst>
           </p:cNvPr>
@@ -123,7 +123,7 @@
           <p:cNvPr id="3" name="TextBox 3">
             <a:extLst>
               <a:ext uri="{FF2B5EF4-FFF2-40B4-BE49-F238E27FC236}">
-                <a16:creationId xmlns:a16="http://schemas.microsoft.com/office/drawing/2014/main" id="{E1C77518-5742-4A24-8C80-9490E4A6B42D}"/>
+                <a16:creationId xmlns:a16="http://schemas.microsoft.com/office/drawing/2014/main" id="{55D52296-2429-4198-BD2C-54E3EBBF5EDF}"/>
               </a:ext>
             </a:extLst>
           </p:cNvPr>
@@ -177,7 +177,7 @@
           <p:cNvPr id="2" name="TextBox 2">
             <a:extLst>
               <a:ext uri="{FF2B5EF4-FFF2-40B4-BE49-F238E27FC236}">
-                <a16:creationId xmlns:a16="http://schemas.microsoft.com/office/drawing/2014/main" id="{6FB11581-0C26-43D4-8C6A-0E282C0D9C16}"/>
+                <a16:creationId xmlns:a16="http://schemas.microsoft.com/office/drawing/2014/main" id="{9114FAF6-B8C5-48AB-958C-C8065373C9AE}"/>
               </a:ext>
             </a:extLst>
           </p:cNvPr>
@@ -206,7 +206,7 @@
           <p:cNvPr id="3" name="TextBox 3">
             <a:extLst>
               <a:ext uri="{FF2B5EF4-FFF2-40B4-BE49-F238E27FC236}">
-                <a16:creationId xmlns:a16="http://schemas.microsoft.com/office/drawing/2014/main" id="{E1C77518-5742-4A24-8C80-9490E4A6B42D}"/>
+                <a16:creationId xmlns:a16="http://schemas.microsoft.com/office/drawing/2014/main" id="{55D52296-2429-4198-BD2C-54E3EBBF5EDF}"/>
               </a:ext>
             </a:extLst>
           </p:cNvPr>
@@ -235,7 +235,7 @@
           <p:cNvPr id="4" name="TextBox 4">
             <a:extLst>
               <a:ext uri="{FF2B5EF4-FFF2-40B4-BE49-F238E27FC236}">
-                <a16:creationId xmlns:a16="http://schemas.microsoft.com/office/drawing/2014/main" id="{E2A19419-8CE1-4FD5-9212-0B2FE4B7EB34}"/>
+                <a16:creationId xmlns:a16="http://schemas.microsoft.com/office/drawing/2014/main" id="{7AE63792-837E-40CB-9A6F-D8DCB0E194D7}"/>
               </a:ext>
             </a:extLst>
           </p:cNvPr>
@@ -264,7 +264,7 @@
           <p:cNvPr id="5" name="TextBox 5">
             <a:extLst>
               <a:ext uri="{FF2B5EF4-FFF2-40B4-BE49-F238E27FC236}">
-                <a16:creationId xmlns:a16="http://schemas.microsoft.com/office/drawing/2014/main" id="{C0544699-0B20-4924-8B79-9F9CBBF6A3E5}"/>
+                <a16:creationId xmlns:a16="http://schemas.microsoft.com/office/drawing/2014/main" id="{1A71309C-908F-4878-A232-52C43E17B822}"/>
               </a:ext>
             </a:extLst>
           </p:cNvPr>
@@ -318,7 +318,7 @@
           <p:cNvPr id="2" name="TextBox 2">
             <a:extLst>
               <a:ext uri="{FF2B5EF4-FFF2-40B4-BE49-F238E27FC236}">
-                <a16:creationId xmlns:a16="http://schemas.microsoft.com/office/drawing/2014/main" id="{6FB11581-0C26-43D4-8C6A-0E282C0D9C16}"/>
+                <a16:creationId xmlns:a16="http://schemas.microsoft.com/office/drawing/2014/main" id="{9114FAF6-B8C5-48AB-958C-C8065373C9AE}"/>
               </a:ext>
             </a:extLst>
           </p:cNvPr>
@@ -347,7 +347,7 @@
           <p:cNvPr id="3" name="TextBox 3">
             <a:extLst>
               <a:ext uri="{FF2B5EF4-FFF2-40B4-BE49-F238E27FC236}">
-                <a16:creationId xmlns:a16="http://schemas.microsoft.com/office/drawing/2014/main" id="{E1C77518-5742-4A24-8C80-9490E4A6B42D}"/>
+                <a16:creationId xmlns:a16="http://schemas.microsoft.com/office/drawing/2014/main" id="{55D52296-2429-4198-BD2C-54E3EBBF5EDF}"/>
               </a:ext>
             </a:extLst>
           </p:cNvPr>
@@ -376,7 +376,7 @@
           <p:cNvPr id="4" name="TextBox 4">
             <a:extLst>
               <a:ext uri="{FF2B5EF4-FFF2-40B4-BE49-F238E27FC236}">
-                <a16:creationId xmlns:a16="http://schemas.microsoft.com/office/drawing/2014/main" id="{E2A19419-8CE1-4FD5-9212-0B2FE4B7EB34}"/>
+                <a16:creationId xmlns:a16="http://schemas.microsoft.com/office/drawing/2014/main" id="{7AE63792-837E-40CB-9A6F-D8DCB0E194D7}"/>
               </a:ext>
             </a:extLst>
           </p:cNvPr>
@@ -405,7 +405,7 @@
           <p:cNvPr id="5" name="TextBox 5">
             <a:extLst>
               <a:ext uri="{FF2B5EF4-FFF2-40B4-BE49-F238E27FC236}">
-                <a16:creationId xmlns:a16="http://schemas.microsoft.com/office/drawing/2014/main" id="{C0544699-0B20-4924-8B79-9F9CBBF6A3E5}"/>
+                <a16:creationId xmlns:a16="http://schemas.microsoft.com/office/drawing/2014/main" id="{1A71309C-908F-4878-A232-52C43E17B822}"/>
               </a:ext>
             </a:extLst>
           </p:cNvPr>
@@ -434,7 +434,7 @@
           <p:cNvPr id="6" name="TextBox 6">
             <a:extLst>
               <a:ext uri="{FF2B5EF4-FFF2-40B4-BE49-F238E27FC236}">
-                <a16:creationId xmlns:a16="http://schemas.microsoft.com/office/drawing/2014/main" id="{8E57C9D9-4D28-423E-A261-647A60B597EB}"/>
+                <a16:creationId xmlns:a16="http://schemas.microsoft.com/office/drawing/2014/main" id="{EB39D2FD-370E-418E-813E-D08D8872DE13}"/>
               </a:ext>
             </a:extLst>
           </p:cNvPr>
@@ -463,7 +463,7 @@
           <p:cNvPr id="7" name="TextBox 7">
             <a:extLst>
               <a:ext uri="{FF2B5EF4-FFF2-40B4-BE49-F238E27FC236}">
-                <a16:creationId xmlns:a16="http://schemas.microsoft.com/office/drawing/2014/main" id="{3FBECD4E-E64A-472F-9517-61C889ECB723}"/>
+                <a16:creationId xmlns:a16="http://schemas.microsoft.com/office/drawing/2014/main" id="{688CDC25-B5AE-4818-87E8-FDB4DF26B976}"/>
               </a:ext>
             </a:extLst>
           </p:cNvPr>
@@ -517,7 +517,7 @@
           <p:cNvPr id="2" name="TextBox 2">
             <a:extLst>
               <a:ext uri="{FF2B5EF4-FFF2-40B4-BE49-F238E27FC236}">
-                <a16:creationId xmlns:a16="http://schemas.microsoft.com/office/drawing/2014/main" id="{6FB11581-0C26-43D4-8C6A-0E282C0D9C16}"/>
+                <a16:creationId xmlns:a16="http://schemas.microsoft.com/office/drawing/2014/main" id="{9114FAF6-B8C5-48AB-958C-C8065373C9AE}"/>
               </a:ext>
             </a:extLst>
           </p:cNvPr>
@@ -546,7 +546,7 @@
           <p:cNvPr id="3" name="TextBox 3">
             <a:extLst>
               <a:ext uri="{FF2B5EF4-FFF2-40B4-BE49-F238E27FC236}">
-                <a16:creationId xmlns:a16="http://schemas.microsoft.com/office/drawing/2014/main" id="{E1C77518-5742-4A24-8C80-9490E4A6B42D}"/>
+                <a16:creationId xmlns:a16="http://schemas.microsoft.com/office/drawing/2014/main" id="{55D52296-2429-4198-BD2C-54E3EBBF5EDF}"/>
               </a:ext>
             </a:extLst>
           </p:cNvPr>
@@ -575,7 +575,7 @@
           <p:cNvPr id="4" name="TextBox 4">
             <a:extLst>
               <a:ext uri="{FF2B5EF4-FFF2-40B4-BE49-F238E27FC236}">
-                <a16:creationId xmlns:a16="http://schemas.microsoft.com/office/drawing/2014/main" id="{E2A19419-8CE1-4FD5-9212-0B2FE4B7EB34}"/>
+                <a16:creationId xmlns:a16="http://schemas.microsoft.com/office/drawing/2014/main" id="{7AE63792-837E-40CB-9A6F-D8DCB0E194D7}"/>
               </a:ext>
             </a:extLst>
           </p:cNvPr>
@@ -604,7 +604,7 @@
           <p:cNvPr id="5" name="TextBox 5">
             <a:extLst>
               <a:ext uri="{FF2B5EF4-FFF2-40B4-BE49-F238E27FC236}">
-                <a16:creationId xmlns:a16="http://schemas.microsoft.com/office/drawing/2014/main" id="{C0544699-0B20-4924-8B79-9F9CBBF6A3E5}"/>
+                <a16:creationId xmlns:a16="http://schemas.microsoft.com/office/drawing/2014/main" id="{1A71309C-908F-4878-A232-52C43E17B822}"/>
               </a:ext>
             </a:extLst>
           </p:cNvPr>
@@ -633,7 +633,7 @@
           <p:cNvPr id="6" name="TextBox 6">
             <a:extLst>
               <a:ext uri="{FF2B5EF4-FFF2-40B4-BE49-F238E27FC236}">
-                <a16:creationId xmlns:a16="http://schemas.microsoft.com/office/drawing/2014/main" id="{8E57C9D9-4D28-423E-A261-647A60B597EB}"/>
+                <a16:creationId xmlns:a16="http://schemas.microsoft.com/office/drawing/2014/main" id="{EB39D2FD-370E-418E-813E-D08D8872DE13}"/>
               </a:ext>
             </a:extLst>
           </p:cNvPr>
@@ -662,7 +662,7 @@
           <p:cNvPr id="7" name="TextBox 7">
             <a:extLst>
               <a:ext uri="{FF2B5EF4-FFF2-40B4-BE49-F238E27FC236}">
-                <a16:creationId xmlns:a16="http://schemas.microsoft.com/office/drawing/2014/main" id="{3FBECD4E-E64A-472F-9517-61C889ECB723}"/>
+                <a16:creationId xmlns:a16="http://schemas.microsoft.com/office/drawing/2014/main" id="{688CDC25-B5AE-4818-87E8-FDB4DF26B976}"/>
               </a:ext>
             </a:extLst>
           </p:cNvPr>
@@ -691,7 +691,7 @@
           <p:cNvPr id="8" name="TextBox 8">
             <a:extLst>
               <a:ext uri="{FF2B5EF4-FFF2-40B4-BE49-F238E27FC236}">
-                <a16:creationId xmlns:a16="http://schemas.microsoft.com/office/drawing/2014/main" id="{8CDD7FCE-C50F-4011-AAB6-FE91C26E9A13}"/>
+                <a16:creationId xmlns:a16="http://schemas.microsoft.com/office/drawing/2014/main" id="{79BCAB92-6AF6-419C-8D7B-D374E3064BA7}"/>
               </a:ext>
             </a:extLst>
           </p:cNvPr>
@@ -720,7 +720,7 @@
           <p:cNvPr id="9" name="TextBox 9">
             <a:extLst>
               <a:ext uri="{FF2B5EF4-FFF2-40B4-BE49-F238E27FC236}">
-                <a16:creationId xmlns:a16="http://schemas.microsoft.com/office/drawing/2014/main" id="{84CD9F61-C46D-45E1-A373-DD4CE78B0089}"/>
+                <a16:creationId xmlns:a16="http://schemas.microsoft.com/office/drawing/2014/main" id="{E2992687-7628-45FE-B165-27E25A4E617B}"/>
               </a:ext>
             </a:extLst>
           </p:cNvPr>
@@ -774,7 +774,7 @@
           <p:cNvPr id="2" name="TextBox 2">
             <a:extLst>
               <a:ext uri="{FF2B5EF4-FFF2-40B4-BE49-F238E27FC236}">
-                <a16:creationId xmlns:a16="http://schemas.microsoft.com/office/drawing/2014/main" id="{6FB11581-0C26-43D4-8C6A-0E282C0D9C16}"/>
+                <a16:creationId xmlns:a16="http://schemas.microsoft.com/office/drawing/2014/main" id="{9114FAF6-B8C5-48AB-958C-C8065373C9AE}"/>
               </a:ext>
             </a:extLst>
           </p:cNvPr>
@@ -803,7 +803,7 @@
           <p:cNvPr id="3" name="TextBox 3">
             <a:extLst>
               <a:ext uri="{FF2B5EF4-FFF2-40B4-BE49-F238E27FC236}">
-                <a16:creationId xmlns:a16="http://schemas.microsoft.com/office/drawing/2014/main" id="{E1C77518-5742-4A24-8C80-9490E4A6B42D}"/>
+                <a16:creationId xmlns:a16="http://schemas.microsoft.com/office/drawing/2014/main" id="{55D52296-2429-4198-BD2C-54E3EBBF5EDF}"/>
               </a:ext>
             </a:extLst>
           </p:cNvPr>
@@ -832,7 +832,7 @@
           <p:cNvPr id="4" name="TextBox 4">
             <a:extLst>
               <a:ext uri="{FF2B5EF4-FFF2-40B4-BE49-F238E27FC236}">
-                <a16:creationId xmlns:a16="http://schemas.microsoft.com/office/drawing/2014/main" id="{E2A19419-8CE1-4FD5-9212-0B2FE4B7EB34}"/>
+                <a16:creationId xmlns:a16="http://schemas.microsoft.com/office/drawing/2014/main" id="{7AE63792-837E-40CB-9A6F-D8DCB0E194D7}"/>
               </a:ext>
             </a:extLst>
           </p:cNvPr>
@@ -861,7 +861,7 @@
           <p:cNvPr id="5" name="TextBox 5">
             <a:extLst>
               <a:ext uri="{FF2B5EF4-FFF2-40B4-BE49-F238E27FC236}">
-                <a16:creationId xmlns:a16="http://schemas.microsoft.com/office/drawing/2014/main" id="{C0544699-0B20-4924-8B79-9F9CBBF6A3E5}"/>
+                <a16:creationId xmlns:a16="http://schemas.microsoft.com/office/drawing/2014/main" id="{1A71309C-908F-4878-A232-52C43E17B822}"/>
               </a:ext>
             </a:extLst>
           </p:cNvPr>
@@ -890,7 +890,7 @@
           <p:cNvPr id="6" name="TextBox 6">
             <a:extLst>
               <a:ext uri="{FF2B5EF4-FFF2-40B4-BE49-F238E27FC236}">
-                <a16:creationId xmlns:a16="http://schemas.microsoft.com/office/drawing/2014/main" id="{8E57C9D9-4D28-423E-A261-647A60B597EB}"/>
+                <a16:creationId xmlns:a16="http://schemas.microsoft.com/office/drawing/2014/main" id="{EB39D2FD-370E-418E-813E-D08D8872DE13}"/>
               </a:ext>
             </a:extLst>
           </p:cNvPr>
@@ -919,7 +919,7 @@
           <p:cNvPr id="7" name="TextBox 7">
             <a:extLst>
               <a:ext uri="{FF2B5EF4-FFF2-40B4-BE49-F238E27FC236}">
-                <a16:creationId xmlns:a16="http://schemas.microsoft.com/office/drawing/2014/main" id="{3FBECD4E-E64A-472F-9517-61C889ECB723}"/>
+                <a16:creationId xmlns:a16="http://schemas.microsoft.com/office/drawing/2014/main" id="{688CDC25-B5AE-4818-87E8-FDB4DF26B976}"/>
               </a:ext>
             </a:extLst>
           </p:cNvPr>
@@ -948,7 +948,7 @@
           <p:cNvPr id="8" name="TextBox 8">
             <a:extLst>
               <a:ext uri="{FF2B5EF4-FFF2-40B4-BE49-F238E27FC236}">
-                <a16:creationId xmlns:a16="http://schemas.microsoft.com/office/drawing/2014/main" id="{8CDD7FCE-C50F-4011-AAB6-FE91C26E9A13}"/>
+                <a16:creationId xmlns:a16="http://schemas.microsoft.com/office/drawing/2014/main" id="{79BCAB92-6AF6-419C-8D7B-D374E3064BA7}"/>
               </a:ext>
             </a:extLst>
           </p:cNvPr>
@@ -977,7 +977,7 @@
           <p:cNvPr id="9" name="TextBox 9">
             <a:extLst>
               <a:ext uri="{FF2B5EF4-FFF2-40B4-BE49-F238E27FC236}">
-                <a16:creationId xmlns:a16="http://schemas.microsoft.com/office/drawing/2014/main" id="{84CD9F61-C46D-45E1-A373-DD4CE78B0089}"/>
+                <a16:creationId xmlns:a16="http://schemas.microsoft.com/office/drawing/2014/main" id="{E2992687-7628-45FE-B165-27E25A4E617B}"/>
               </a:ext>
             </a:extLst>
           </p:cNvPr>
@@ -1006,7 +1006,7 @@
           <p:cNvPr id="10" name="TextBox 10">
             <a:extLst>
               <a:ext uri="{FF2B5EF4-FFF2-40B4-BE49-F238E27FC236}">
-                <a16:creationId xmlns:a16="http://schemas.microsoft.com/office/drawing/2014/main" id="{E95FE9F1-7AE5-4F6F-910C-AEEB945C0164}"/>
+                <a16:creationId xmlns:a16="http://schemas.microsoft.com/office/drawing/2014/main" id="{BF64E1B5-7623-442B-B187-617B83A0E7B2}"/>
               </a:ext>
             </a:extLst>
           </p:cNvPr>
@@ -1035,7 +1035,7 @@
           <p:cNvPr id="11" name="TextBox 11">
             <a:extLst>
               <a:ext uri="{FF2B5EF4-FFF2-40B4-BE49-F238E27FC236}">
-                <a16:creationId xmlns:a16="http://schemas.microsoft.com/office/drawing/2014/main" id="{E4D9C918-E5B0-4D45-A713-57EA77642088}"/>
+                <a16:creationId xmlns:a16="http://schemas.microsoft.com/office/drawing/2014/main" id="{A6D0EE91-A4E3-4F42-8916-A78E42836BFB}"/>
               </a:ext>
             </a:extLst>
           </p:cNvPr>

</xml_diff>